<commit_message>
sd-12-012: the congestion triples the middle third of the shortest route, not one segment; slide 7 relabelled
Co-Authored-By: Claude Sonnet 5.5 <noreply@anthropic.com>
Claude-Session: https://claude.ai/code/session_01YWnTQqPDLSbUsxkfwNWsvG
</commit_message>
<xml_diff>
--- a/system-design-101/vi/lessons/sd-12-012/slides/sd-12-012.pptx
+++ b/system-design-101/vi/lessons/sd-12-012/slides/sd-12-012.pptx
@@ -8998,7 +8998,7 @@
                 <a:ea typeface="Be Vietnam Pro" pitchFamily="34" charset="-122"/>
                 <a:cs typeface="Be Vietnam Pro" pitchFamily="34" charset="-120"/>
               </a:rPr>
-              <a:t>KHI</a:t>
+              <a:t>KẸT</a:t>
             </a:r>
             <a:r>
               <a:rPr lang="en-US" sz="2100" b="1" spc="224" kern="0" dirty="0">
@@ -9009,7 +9009,18 @@
                 <a:ea typeface="Be Vietnam Pro" pitchFamily="34" charset="-122"/>
                 <a:cs typeface="Be Vietnam Pro" pitchFamily="34" charset="-120"/>
               </a:rPr>
-              <a:t> KẸT XE</a:t>
+              <a:t> Ở GIỮA</a:t>
+            </a:r>
+            <a:r>
+              <a:rPr lang="en-US" sz="2100" b="1" spc="227" kern="0" dirty="0">
+                <a:solidFill>
+                  <a:srgbClr val="B45309"/>
+                </a:solidFill>
+                <a:latin typeface="Be Vietnam Pro" pitchFamily="34" charset="0"/>
+                <a:ea typeface="Be Vietnam Pro" pitchFamily="34" charset="-122"/>
+                <a:cs typeface="Be Vietnam Pro" pitchFamily="34" charset="-120"/>
+              </a:rPr>
+              <a:t> TUYẾN</a:t>
             </a:r>
             <a:endParaRPr lang="en-US" sz="2100" dirty="0"/>
           </a:p>

</xml_diff>